<commit_message>
Añado mis evidencias individuales fasae 1
</commit_message>
<xml_diff>
--- a/Fase 1/Evidencias Grupales/Presentación idea de proyecto.pptx
+++ b/Fase 1/Evidencias Grupales/Presentación idea de proyecto.pptx
@@ -29,7 +29,7 @@
     <p:sldId id="270" r:id="rId20"/>
     <p:sldId id="271" r:id="rId21"/>
   </p:sldIdLst>
-  <p:sldSz cx="12191695" cy="6858000"/>
+  <p:sldSz cx="12192000" cy="6858000"/>
   <p:notesSz cx="6858000" cy="9144000"/>
   <p:defaultTextStyle>
     <a:defPPr>
@@ -143,6 +143,35 @@
     </p:ext>
   </p:extLst>
 </p:presentation>
+</file>
+
+<file path=ppt/changesInfos/changesInfo1.xml><?xml version="1.0" encoding="utf-8"?>
+<pc:chgInfo xmlns:a="http://schemas.openxmlformats.org/drawingml/2006/main" xmlns:r="http://schemas.openxmlformats.org/officeDocument/2006/relationships" xmlns:ac="http://schemas.microsoft.com/office/drawing/2013/main/command" xmlns:pc="http://schemas.microsoft.com/office/powerpoint/2013/main/command">
+  <pc:docChgLst>
+    <pc:chgData name="yerko loncon" userId="827ad9408100a45d" providerId="LiveId" clId="{5B506CAC-8DA0-4B84-849B-72A823F8B7DF}"/>
+    <pc:docChg chg="modSld">
+      <pc:chgData name="yerko loncon" userId="827ad9408100a45d" providerId="LiveId" clId="{5B506CAC-8DA0-4B84-849B-72A823F8B7DF}" dt="2026-10-21T19:01:53.589" v="1" actId="20577"/>
+      <pc:docMkLst>
+        <pc:docMk/>
+      </pc:docMkLst>
+      <pc:sldChg chg="modSp mod">
+        <pc:chgData name="yerko loncon" userId="827ad9408100a45d" providerId="LiveId" clId="{5B506CAC-8DA0-4B84-849B-72A823F8B7DF}" dt="2026-10-21T19:01:53.589" v="1" actId="20577"/>
+        <pc:sldMkLst>
+          <pc:docMk/>
+          <pc:sldMk cId="0" sldId="256"/>
+        </pc:sldMkLst>
+        <pc:spChg chg="mod">
+          <ac:chgData name="yerko loncon" userId="827ad9408100a45d" providerId="LiveId" clId="{5B506CAC-8DA0-4B84-849B-72A823F8B7DF}" dt="2026-10-21T19:01:53.589" v="1" actId="20577"/>
+          <ac:spMkLst>
+            <pc:docMk/>
+            <pc:sldMk cId="0" sldId="256"/>
+            <ac:spMk id="10" creationId="{00000000-0000-0000-0000-000000000000}"/>
+          </ac:spMkLst>
+        </pc:spChg>
+      </pc:sldChg>
+    </pc:docChg>
+  </pc:docChgLst>
+</pc:chgInfo>
 </file>
 
 <file path=ppt/notesMasters/notesMaster1.xml><?xml version="1.0" encoding="utf-8"?>
@@ -4848,31 +4877,13 @@
               <a:t>· </a:t>
             </a:r>
             <a:r>
-              <a:rPr lang="es-ES" sz="1400" b="0" i="0" dirty="0" err="1">
+              <a:rPr lang="es-ES" sz="1400" b="0" i="0" dirty="0">
                 <a:solidFill>
                   <a:srgbClr val="F4E7CC"/>
                 </a:solidFill>
                 <a:latin typeface="Calibri"/>
               </a:rPr>
-              <a:t>Yerko</a:t>
-            </a:r>
-            <a:r>
-              <a:rPr lang="es-ES" sz="1400" b="0" i="0" dirty="0">
-                <a:solidFill>
-                  <a:srgbClr val="F4E7CC"/>
-                </a:solidFill>
-                <a:latin typeface="Calibri"/>
-              </a:rPr>
-              <a:t> </a:t>
-            </a:r>
-            <a:r>
-              <a:rPr lang="es-ES" sz="1400" b="0" i="0" dirty="0" err="1">
-                <a:solidFill>
-                  <a:srgbClr val="F4E7CC"/>
-                </a:solidFill>
-                <a:latin typeface="Calibri"/>
-              </a:rPr>
-              <a:t>Loncon</a:t>
+              <a:t>Yerko Loncón</a:t>
             </a:r>
             <a:endParaRPr sz="1400" b="0" i="0" dirty="0">
               <a:solidFill>
@@ -6510,6 +6521,7 @@
           <a:lstStyle/>
           <a:p>
             <a:pPr algn="ctr"/>
+            <a:endParaRPr/>
           </a:p>
         </p:txBody>
       </p:sp>
@@ -6558,6 +6570,7 @@
           <a:lstStyle/>
           <a:p>
             <a:pPr algn="ctr"/>
+            <a:endParaRPr/>
           </a:p>
         </p:txBody>
       </p:sp>
@@ -6578,7 +6591,7 @@
           <a:noFill/>
         </p:spPr>
         <p:txBody>
-          <a:bodyPr wrap="square" anchor="ctr" lIns="27432" rIns="27432" tIns="27432" bIns="27432">
+          <a:bodyPr wrap="square" lIns="27432" tIns="27432" rIns="27432" bIns="27432" anchor="ctr">
             <a:spAutoFit/>
           </a:bodyPr>
           <a:lstStyle/>
@@ -6645,6 +6658,7 @@
           <a:lstStyle/>
           <a:p>
             <a:pPr algn="ctr"/>
+            <a:endParaRPr/>
           </a:p>
         </p:txBody>
       </p:sp>
@@ -6693,6 +6707,7 @@
           <a:lstStyle/>
           <a:p>
             <a:pPr algn="ctr"/>
+            <a:endParaRPr/>
           </a:p>
         </p:txBody>
       </p:sp>
@@ -6713,7 +6728,7 @@
           <a:noFill/>
         </p:spPr>
         <p:txBody>
-          <a:bodyPr wrap="square" anchor="ctr" lIns="27432" rIns="27432" tIns="27432" bIns="27432">
+          <a:bodyPr wrap="square" lIns="27432" tIns="27432" rIns="27432" bIns="27432" anchor="ctr">
             <a:spAutoFit/>
           </a:bodyPr>
           <a:lstStyle/>
@@ -6780,6 +6795,7 @@
           <a:lstStyle/>
           <a:p>
             <a:pPr algn="ctr"/>
+            <a:endParaRPr/>
           </a:p>
         </p:txBody>
       </p:sp>
@@ -6824,7 +6840,7 @@
           <a:noFill/>
         </p:spPr>
         <p:txBody>
-          <a:bodyPr wrap="square" anchor="t" lIns="27432" rIns="27432" tIns="27432" bIns="27432">
+          <a:bodyPr wrap="square" lIns="27432" tIns="27432" rIns="27432" bIns="27432" anchor="t">
             <a:spAutoFit/>
           </a:bodyPr>
           <a:lstStyle/>
@@ -6863,7 +6879,7 @@
           <a:noFill/>
         </p:spPr>
         <p:txBody>
-          <a:bodyPr wrap="square" anchor="t" lIns="27432" rIns="27432" tIns="27432" bIns="27432">
+          <a:bodyPr wrap="square" lIns="27432" tIns="27432" rIns="27432" bIns="27432" anchor="t">
             <a:spAutoFit/>
           </a:bodyPr>
           <a:lstStyle/>
@@ -6930,6 +6946,7 @@
           <a:lstStyle/>
           <a:p>
             <a:pPr algn="ctr"/>
+            <a:endParaRPr/>
           </a:p>
         </p:txBody>
       </p:sp>
@@ -6974,7 +6991,7 @@
           <a:noFill/>
         </p:spPr>
         <p:txBody>
-          <a:bodyPr wrap="square" anchor="t" lIns="27432" rIns="27432" tIns="27432" bIns="27432">
+          <a:bodyPr wrap="square" lIns="27432" tIns="27432" rIns="27432" bIns="27432" anchor="t">
             <a:spAutoFit/>
           </a:bodyPr>
           <a:lstStyle/>
@@ -7013,7 +7030,7 @@
           <a:noFill/>
         </p:spPr>
         <p:txBody>
-          <a:bodyPr wrap="square" anchor="t" lIns="27432" rIns="27432" tIns="27432" bIns="27432">
+          <a:bodyPr wrap="square" lIns="27432" tIns="27432" rIns="27432" bIns="27432" anchor="t">
             <a:spAutoFit/>
           </a:bodyPr>
           <a:lstStyle/>
@@ -7054,7 +7071,6 @@
               <a:srgbClr val="C9551F"/>
             </a:solidFill>
             <a:tailEnd type="triangle"/>
-            <a:headEnd type="triangle"/>
           </a:ln>
         </p:spPr>
         <p:style>
@@ -7089,7 +7105,7 @@
           <a:noFill/>
         </p:spPr>
         <p:txBody>
-          <a:bodyPr wrap="square" anchor="t" lIns="27432" rIns="27432" tIns="27432" bIns="27432">
+          <a:bodyPr wrap="square" lIns="27432" tIns="27432" rIns="27432" bIns="27432" anchor="t">
             <a:spAutoFit/>
           </a:bodyPr>
           <a:lstStyle/>
@@ -7156,6 +7172,7 @@
           <a:lstStyle/>
           <a:p>
             <a:pPr algn="ctr"/>
+            <a:endParaRPr/>
           </a:p>
         </p:txBody>
       </p:sp>
@@ -7200,7 +7217,7 @@
           <a:noFill/>
         </p:spPr>
         <p:txBody>
-          <a:bodyPr wrap="square" anchor="t" lIns="27432" rIns="27432" tIns="27432" bIns="27432">
+          <a:bodyPr wrap="square" lIns="27432" tIns="27432" rIns="27432" bIns="27432" anchor="t">
             <a:spAutoFit/>
           </a:bodyPr>
           <a:lstStyle/>
@@ -7239,7 +7256,7 @@
           <a:noFill/>
         </p:spPr>
         <p:txBody>
-          <a:bodyPr wrap="square" anchor="t" lIns="27432" rIns="27432" tIns="27432" bIns="27432">
+          <a:bodyPr wrap="square" lIns="27432" tIns="27432" rIns="27432" bIns="27432" anchor="t">
             <a:spAutoFit/>
           </a:bodyPr>
           <a:lstStyle/>
@@ -7314,7 +7331,7 @@
           <a:noFill/>
         </p:spPr>
         <p:txBody>
-          <a:bodyPr wrap="square" anchor="t" lIns="27432" rIns="27432" tIns="27432" bIns="27432">
+          <a:bodyPr wrap="square" lIns="27432" tIns="27432" rIns="27432" bIns="27432" anchor="t">
             <a:spAutoFit/>
           </a:bodyPr>
           <a:lstStyle/>
@@ -16138,6 +16155,7 @@
           <a:lstStyle/>
           <a:p>
             <a:pPr algn="ctr"/>
+            <a:endParaRPr/>
           </a:p>
         </p:txBody>
       </p:sp>
@@ -16186,6 +16204,7 @@
           <a:lstStyle/>
           <a:p>
             <a:pPr algn="ctr"/>
+            <a:endParaRPr/>
           </a:p>
         </p:txBody>
       </p:sp>
@@ -16198,7 +16217,7 @@
           <p:nvPr/>
         </p:nvPicPr>
         <p:blipFill>
-          <a:blip r:embed="rId6"/>
+          <a:blip r:embed="rId4"/>
           <a:stretch>
             <a:fillRect/>
           </a:stretch>
@@ -16230,7 +16249,7 @@
           <a:noFill/>
         </p:spPr>
         <p:txBody>
-          <a:bodyPr wrap="square" anchor="t" lIns="27432" rIns="27432" tIns="27432" bIns="27432">
+          <a:bodyPr wrap="square" lIns="27432" tIns="27432" rIns="27432" bIns="27432" anchor="t">
             <a:spAutoFit/>
           </a:bodyPr>
           <a:lstStyle/>
@@ -16269,7 +16288,7 @@
           <a:noFill/>
         </p:spPr>
         <p:txBody>
-          <a:bodyPr wrap="square" anchor="t" lIns="27432" rIns="27432" tIns="27432" bIns="27432">
+          <a:bodyPr wrap="square" lIns="27432" tIns="27432" rIns="27432" bIns="27432" anchor="t">
             <a:spAutoFit/>
           </a:bodyPr>
           <a:lstStyle/>
@@ -16336,6 +16355,7 @@
           <a:lstStyle/>
           <a:p>
             <a:pPr algn="ctr"/>
+            <a:endParaRPr/>
           </a:p>
         </p:txBody>
       </p:sp>
@@ -16348,7 +16368,7 @@
           <p:nvPr/>
         </p:nvPicPr>
         <p:blipFill>
-          <a:blip r:embed="rId10"/>
+          <a:blip r:embed="rId5"/>
           <a:stretch>
             <a:fillRect/>
           </a:stretch>
@@ -16380,7 +16400,7 @@
           <a:noFill/>
         </p:spPr>
         <p:txBody>
-          <a:bodyPr wrap="square" anchor="t" lIns="27432" rIns="27432" tIns="27432" bIns="27432">
+          <a:bodyPr wrap="square" lIns="27432" tIns="27432" rIns="27432" bIns="27432" anchor="t">
             <a:spAutoFit/>
           </a:bodyPr>
           <a:lstStyle/>
@@ -16419,7 +16439,7 @@
           <a:noFill/>
         </p:spPr>
         <p:txBody>
-          <a:bodyPr wrap="square" anchor="t" lIns="27432" rIns="27432" tIns="27432" bIns="27432">
+          <a:bodyPr wrap="square" lIns="27432" tIns="27432" rIns="27432" bIns="27432" anchor="t">
             <a:spAutoFit/>
           </a:bodyPr>
           <a:lstStyle/>
@@ -16522,6 +16542,7 @@
           <a:lstStyle/>
           <a:p>
             <a:pPr algn="ctr"/>
+            <a:endParaRPr/>
           </a:p>
         </p:txBody>
       </p:sp>
@@ -16534,7 +16555,7 @@
           <p:nvPr/>
         </p:nvPicPr>
         <p:blipFill>
-          <a:blip r:embed="rId11"/>
+          <a:blip r:embed="rId6"/>
           <a:stretch>
             <a:fillRect/>
           </a:stretch>
@@ -16566,7 +16587,7 @@
           <a:noFill/>
         </p:spPr>
         <p:txBody>
-          <a:bodyPr wrap="square" anchor="t" lIns="27432" rIns="27432" tIns="27432" bIns="27432">
+          <a:bodyPr wrap="square" lIns="27432" tIns="27432" rIns="27432" bIns="27432" anchor="t">
             <a:spAutoFit/>
           </a:bodyPr>
           <a:lstStyle/>
@@ -16605,7 +16626,7 @@
           <a:noFill/>
         </p:spPr>
         <p:txBody>
-          <a:bodyPr wrap="square" anchor="t" lIns="27432" rIns="27432" tIns="27432" bIns="27432">
+          <a:bodyPr wrap="square" lIns="27432" tIns="27432" rIns="27432" bIns="27432" anchor="t">
             <a:spAutoFit/>
           </a:bodyPr>
           <a:lstStyle/>
@@ -16708,6 +16729,7 @@
           <a:lstStyle/>
           <a:p>
             <a:pPr algn="ctr"/>
+            <a:endParaRPr/>
           </a:p>
         </p:txBody>
       </p:sp>
@@ -16720,7 +16742,7 @@
           <p:nvPr/>
         </p:nvPicPr>
         <p:blipFill>
-          <a:blip r:embed="rId12"/>
+          <a:blip r:embed="rId7"/>
           <a:stretch>
             <a:fillRect/>
           </a:stretch>
@@ -16752,7 +16774,7 @@
           <a:noFill/>
         </p:spPr>
         <p:txBody>
-          <a:bodyPr wrap="square" anchor="t" lIns="27432" rIns="27432" tIns="27432" bIns="27432">
+          <a:bodyPr wrap="square" lIns="27432" tIns="27432" rIns="27432" bIns="27432" anchor="t">
             <a:spAutoFit/>
           </a:bodyPr>
           <a:lstStyle/>
@@ -16791,7 +16813,7 @@
           <a:noFill/>
         </p:spPr>
         <p:txBody>
-          <a:bodyPr wrap="square" anchor="t" lIns="27432" rIns="27432" tIns="27432" bIns="27432">
+          <a:bodyPr wrap="square" lIns="27432" tIns="27432" rIns="27432" bIns="27432" anchor="t">
             <a:spAutoFit/>
           </a:bodyPr>
           <a:lstStyle/>
@@ -16894,6 +16916,7 @@
           <a:lstStyle/>
           <a:p>
             <a:pPr algn="ctr"/>
+            <a:endParaRPr/>
           </a:p>
         </p:txBody>
       </p:sp>
@@ -16906,7 +16929,7 @@
           <p:nvPr/>
         </p:nvPicPr>
         <p:blipFill>
-          <a:blip r:embed="rId5"/>
+          <a:blip r:embed="rId8"/>
           <a:stretch>
             <a:fillRect/>
           </a:stretch>
@@ -16938,7 +16961,7 @@
           <a:noFill/>
         </p:spPr>
         <p:txBody>
-          <a:bodyPr wrap="square" anchor="t" lIns="27432" rIns="27432" tIns="27432" bIns="27432">
+          <a:bodyPr wrap="square" lIns="27432" tIns="27432" rIns="27432" bIns="27432" anchor="t">
             <a:spAutoFit/>
           </a:bodyPr>
           <a:lstStyle/>
@@ -16977,7 +17000,7 @@
           <a:noFill/>
         </p:spPr>
         <p:txBody>
-          <a:bodyPr wrap="square" anchor="t" lIns="27432" rIns="27432" tIns="27432" bIns="27432">
+          <a:bodyPr wrap="square" lIns="27432" tIns="27432" rIns="27432" bIns="27432" anchor="t">
             <a:spAutoFit/>
           </a:bodyPr>
           <a:lstStyle/>
@@ -17052,7 +17075,7 @@
           <a:noFill/>
         </p:spPr>
         <p:txBody>
-          <a:bodyPr wrap="square" anchor="t" lIns="27432" rIns="27432" tIns="27432" bIns="27432">
+          <a:bodyPr wrap="square" lIns="27432" tIns="27432" rIns="27432" bIns="27432" anchor="t">
             <a:spAutoFit/>
           </a:bodyPr>
           <a:lstStyle/>
@@ -24298,7 +24321,7 @@
           <a:noFill/>
         </p:spPr>
         <p:txBody>
-          <a:bodyPr wrap="square" anchor="t" lIns="27432" rIns="27432" tIns="27432" bIns="27432">
+          <a:bodyPr wrap="square" lIns="27432" tIns="27432" rIns="27432" bIns="27432" anchor="t">
             <a:spAutoFit/>
           </a:bodyPr>
           <a:lstStyle/>
@@ -24365,6 +24388,7 @@
           <a:lstStyle/>
           <a:p>
             <a:pPr algn="ctr"/>
+            <a:endParaRPr/>
           </a:p>
         </p:txBody>
       </p:sp>
@@ -24409,7 +24433,7 @@
           <a:noFill/>
         </p:spPr>
         <p:txBody>
-          <a:bodyPr wrap="square" anchor="t" lIns="27432" rIns="27432" tIns="27432" bIns="27432">
+          <a:bodyPr wrap="square" lIns="27432" tIns="27432" rIns="27432" bIns="27432" anchor="t">
             <a:spAutoFit/>
           </a:bodyPr>
           <a:lstStyle/>
@@ -24448,7 +24472,7 @@
           <a:noFill/>
         </p:spPr>
         <p:txBody>
-          <a:bodyPr wrap="square" anchor="t" lIns="27432" rIns="27432" tIns="27432" bIns="27432">
+          <a:bodyPr wrap="square" lIns="27432" tIns="27432" rIns="27432" bIns="27432" anchor="t">
             <a:spAutoFit/>
           </a:bodyPr>
           <a:lstStyle/>
@@ -24515,6 +24539,7 @@
           <a:lstStyle/>
           <a:p>
             <a:pPr algn="ctr"/>
+            <a:endParaRPr/>
           </a:p>
         </p:txBody>
       </p:sp>
@@ -24527,7 +24552,7 @@
           <p:nvPr/>
         </p:nvPicPr>
         <p:blipFill>
-          <a:blip r:embed="rId7"/>
+          <a:blip r:embed="rId5"/>
           <a:stretch>
             <a:fillRect/>
           </a:stretch>
@@ -24559,7 +24584,7 @@
           <a:noFill/>
         </p:spPr>
         <p:txBody>
-          <a:bodyPr wrap="square" anchor="t" lIns="27432" rIns="27432" tIns="27432" bIns="27432">
+          <a:bodyPr wrap="square" lIns="27432" tIns="27432" rIns="27432" bIns="27432" anchor="t">
             <a:spAutoFit/>
           </a:bodyPr>
           <a:lstStyle/>
@@ -24598,7 +24623,7 @@
           <a:noFill/>
         </p:spPr>
         <p:txBody>
-          <a:bodyPr wrap="square" anchor="t" lIns="27432" rIns="27432" tIns="27432" bIns="27432">
+          <a:bodyPr wrap="square" lIns="27432" tIns="27432" rIns="27432" bIns="27432" anchor="t">
             <a:spAutoFit/>
           </a:bodyPr>
           <a:lstStyle/>
@@ -24665,6 +24690,7 @@
           <a:lstStyle/>
           <a:p>
             <a:pPr algn="ctr"/>
+            <a:endParaRPr/>
           </a:p>
         </p:txBody>
       </p:sp>
@@ -24677,7 +24703,7 @@
           <p:nvPr/>
         </p:nvPicPr>
         <p:blipFill>
-          <a:blip r:embed="rId5"/>
+          <a:blip r:embed="rId6"/>
           <a:stretch>
             <a:fillRect/>
           </a:stretch>
@@ -24709,7 +24735,7 @@
           <a:noFill/>
         </p:spPr>
         <p:txBody>
-          <a:bodyPr wrap="square" anchor="t" lIns="27432" rIns="27432" tIns="27432" bIns="27432">
+          <a:bodyPr wrap="square" lIns="27432" tIns="27432" rIns="27432" bIns="27432" anchor="t">
             <a:spAutoFit/>
           </a:bodyPr>
           <a:lstStyle/>
@@ -24748,7 +24774,7 @@
           <a:noFill/>
         </p:spPr>
         <p:txBody>
-          <a:bodyPr wrap="square" anchor="t" lIns="27432" rIns="27432" tIns="27432" bIns="27432">
+          <a:bodyPr wrap="square" lIns="27432" tIns="27432" rIns="27432" bIns="27432" anchor="t">
             <a:spAutoFit/>
           </a:bodyPr>
           <a:lstStyle/>
@@ -24815,6 +24841,7 @@
           <a:lstStyle/>
           <a:p>
             <a:pPr algn="ctr"/>
+            <a:endParaRPr/>
           </a:p>
         </p:txBody>
       </p:sp>
@@ -24827,7 +24854,7 @@
           <p:nvPr/>
         </p:nvPicPr>
         <p:blipFill>
-          <a:blip r:embed="rId6"/>
+          <a:blip r:embed="rId7"/>
           <a:stretch>
             <a:fillRect/>
           </a:stretch>
@@ -24859,7 +24886,7 @@
           <a:noFill/>
         </p:spPr>
         <p:txBody>
-          <a:bodyPr wrap="square" anchor="t" lIns="27432" rIns="27432" tIns="27432" bIns="27432">
+          <a:bodyPr wrap="square" lIns="27432" tIns="27432" rIns="27432" bIns="27432" anchor="t">
             <a:spAutoFit/>
           </a:bodyPr>
           <a:lstStyle/>
@@ -24898,7 +24925,7 @@
           <a:noFill/>
         </p:spPr>
         <p:txBody>
-          <a:bodyPr wrap="square" anchor="t" lIns="27432" rIns="27432" tIns="27432" bIns="27432">
+          <a:bodyPr wrap="square" lIns="27432" tIns="27432" rIns="27432" bIns="27432" anchor="t">
             <a:spAutoFit/>
           </a:bodyPr>
           <a:lstStyle/>
@@ -24965,6 +24992,7 @@
           <a:lstStyle/>
           <a:p>
             <a:pPr algn="ctr"/>
+            <a:endParaRPr/>
           </a:p>
         </p:txBody>
       </p:sp>
@@ -25009,7 +25037,7 @@
           <a:noFill/>
         </p:spPr>
         <p:txBody>
-          <a:bodyPr wrap="square" anchor="t" lIns="27432" rIns="27432" tIns="27432" bIns="27432">
+          <a:bodyPr wrap="square" lIns="27432" tIns="27432" rIns="27432" bIns="27432" anchor="t">
             <a:spAutoFit/>
           </a:bodyPr>
           <a:lstStyle/>
@@ -25048,7 +25076,7 @@
           <a:noFill/>
         </p:spPr>
         <p:txBody>
-          <a:bodyPr wrap="square" anchor="t" lIns="27432" rIns="27432" tIns="27432" bIns="27432">
+          <a:bodyPr wrap="square" lIns="27432" tIns="27432" rIns="27432" bIns="27432" anchor="t">
             <a:spAutoFit/>
           </a:bodyPr>
           <a:lstStyle/>

</xml_diff>